<commit_message>
Updated no labels combined figure (updated floor plan)
</commit_message>
<xml_diff>
--- a/_misc/figure1_files/setup_with_person_on_photo/setup_slide_with_walkingpath_no_labels.pptx
+++ b/_misc/figure1_files/setup_with_person_on_photo/setup_slide_with_walkingpath_no_labels.pptx
@@ -261,7 +261,7 @@
           <a:p>
             <a:fld id="{61088BA3-3677-42F1-90B8-66FDAEF4E117}" type="datetimeFigureOut">
               <a:rPr lang="nl-BE" smtClean="0"/>
-              <a:t>30/07/2025</a:t>
+              <a:t>8/08/2025</a:t>
             </a:fld>
             <a:endParaRPr lang="nl-BE"/>
           </a:p>
@@ -461,7 +461,7 @@
           <a:p>
             <a:fld id="{61088BA3-3677-42F1-90B8-66FDAEF4E117}" type="datetimeFigureOut">
               <a:rPr lang="nl-BE" smtClean="0"/>
-              <a:t>30/07/2025</a:t>
+              <a:t>8/08/2025</a:t>
             </a:fld>
             <a:endParaRPr lang="nl-BE"/>
           </a:p>
@@ -671,7 +671,7 @@
           <a:p>
             <a:fld id="{61088BA3-3677-42F1-90B8-66FDAEF4E117}" type="datetimeFigureOut">
               <a:rPr lang="nl-BE" smtClean="0"/>
-              <a:t>30/07/2025</a:t>
+              <a:t>8/08/2025</a:t>
             </a:fld>
             <a:endParaRPr lang="nl-BE"/>
           </a:p>
@@ -871,7 +871,7 @@
           <a:p>
             <a:fld id="{61088BA3-3677-42F1-90B8-66FDAEF4E117}" type="datetimeFigureOut">
               <a:rPr lang="nl-BE" smtClean="0"/>
-              <a:t>30/07/2025</a:t>
+              <a:t>8/08/2025</a:t>
             </a:fld>
             <a:endParaRPr lang="nl-BE"/>
           </a:p>
@@ -1147,7 +1147,7 @@
           <a:p>
             <a:fld id="{61088BA3-3677-42F1-90B8-66FDAEF4E117}" type="datetimeFigureOut">
               <a:rPr lang="nl-BE" smtClean="0"/>
-              <a:t>30/07/2025</a:t>
+              <a:t>8/08/2025</a:t>
             </a:fld>
             <a:endParaRPr lang="nl-BE"/>
           </a:p>
@@ -1415,7 +1415,7 @@
           <a:p>
             <a:fld id="{61088BA3-3677-42F1-90B8-66FDAEF4E117}" type="datetimeFigureOut">
               <a:rPr lang="nl-BE" smtClean="0"/>
-              <a:t>30/07/2025</a:t>
+              <a:t>8/08/2025</a:t>
             </a:fld>
             <a:endParaRPr lang="nl-BE"/>
           </a:p>
@@ -1830,7 +1830,7 @@
           <a:p>
             <a:fld id="{61088BA3-3677-42F1-90B8-66FDAEF4E117}" type="datetimeFigureOut">
               <a:rPr lang="nl-BE" smtClean="0"/>
-              <a:t>30/07/2025</a:t>
+              <a:t>8/08/2025</a:t>
             </a:fld>
             <a:endParaRPr lang="nl-BE"/>
           </a:p>
@@ -1972,7 +1972,7 @@
           <a:p>
             <a:fld id="{61088BA3-3677-42F1-90B8-66FDAEF4E117}" type="datetimeFigureOut">
               <a:rPr lang="nl-BE" smtClean="0"/>
-              <a:t>30/07/2025</a:t>
+              <a:t>8/08/2025</a:t>
             </a:fld>
             <a:endParaRPr lang="nl-BE"/>
           </a:p>
@@ -2085,7 +2085,7 @@
           <a:p>
             <a:fld id="{61088BA3-3677-42F1-90B8-66FDAEF4E117}" type="datetimeFigureOut">
               <a:rPr lang="nl-BE" smtClean="0"/>
-              <a:t>30/07/2025</a:t>
+              <a:t>8/08/2025</a:t>
             </a:fld>
             <a:endParaRPr lang="nl-BE"/>
           </a:p>
@@ -2398,7 +2398,7 @@
           <a:p>
             <a:fld id="{61088BA3-3677-42F1-90B8-66FDAEF4E117}" type="datetimeFigureOut">
               <a:rPr lang="nl-BE" smtClean="0"/>
-              <a:t>30/07/2025</a:t>
+              <a:t>8/08/2025</a:t>
             </a:fld>
             <a:endParaRPr lang="nl-BE"/>
           </a:p>
@@ -2687,7 +2687,7 @@
           <a:p>
             <a:fld id="{61088BA3-3677-42F1-90B8-66FDAEF4E117}" type="datetimeFigureOut">
               <a:rPr lang="nl-BE" smtClean="0"/>
-              <a:t>30/07/2025</a:t>
+              <a:t>8/08/2025</a:t>
             </a:fld>
             <a:endParaRPr lang="nl-BE"/>
           </a:p>
@@ -2930,7 +2930,7 @@
           <a:p>
             <a:fld id="{61088BA3-3677-42F1-90B8-66FDAEF4E117}" type="datetimeFigureOut">
               <a:rPr lang="nl-BE" smtClean="0"/>
-              <a:t>30/07/2025</a:t>
+              <a:t>8/08/2025</a:t>
             </a:fld>
             <a:endParaRPr lang="nl-BE"/>
           </a:p>
@@ -3385,10 +3385,10 @@
       </p:pic>
       <p:pic>
         <p:nvPicPr>
-          <p:cNvPr id="2" name="Afbeelding 1" descr="Afbeelding met tekst, diagram, schermopname, lijn&#10;&#10;Door AI gegenereerde inhoud is mogelijk onjuist.">
-            <a:extLst>
-              <a:ext uri="{FF2B5EF4-FFF2-40B4-BE49-F238E27FC236}">
-                <a16:creationId xmlns:a16="http://schemas.microsoft.com/office/drawing/2014/main" id="{A3B1DCFA-CC54-5EC7-390F-75F320EC9E6C}"/>
+          <p:cNvPr id="4" name="Afbeelding 3" descr="Afbeelding met tekst, schermopname, diagram, lijn&#10;&#10;Door AI gegenereerde inhoud is mogelijk onjuist.">
+            <a:extLst>
+              <a:ext uri="{FF2B5EF4-FFF2-40B4-BE49-F238E27FC236}">
+                <a16:creationId xmlns:a16="http://schemas.microsoft.com/office/drawing/2014/main" id="{C0CEBC09-7BA9-51A6-2487-EEF0DB7C588D}"/>
               </a:ext>
             </a:extLst>
           </p:cNvPr>
@@ -3411,8 +3411,8 @@
         </p:blipFill>
         <p:spPr>
           <a:xfrm>
-            <a:off x="5257800" y="354843"/>
-            <a:ext cx="6934200" cy="3578942"/>
+            <a:off x="5333000" y="426301"/>
+            <a:ext cx="6859000" cy="3578942"/>
           </a:xfrm>
           <a:prstGeom prst="rect">
             <a:avLst/>

</xml_diff>